<commit_message>
docs(slides): add Section 7.19, so the deck states the control's condition
The deck presents the scramble control as a requirement -- slide 31 has it built
into the screening tool, the Summary lists it among what was delivered -- and
7.19 puts a measured condition on it. A deck that gives the rule without the
condition now overstates it.

One slide, placed immediately after the wet-lab slide it depends on: the two
margins (+19.11 for measured binders, +17.93 for non-binders, Welch p = 0.751),
the AUC before and after subtracting scrambles (0.672 to 0.581), and the
difference with its interval. The callout carries the mechanism rather than the
verdict -- a permutation of a 15-residue peptide is still a plausible ligand, a
permutation of a 100-residue protein is not a protein -- and the note states the
condition the recommendation gains.

Geometry checked: 7.00 in against a 7.08 in footer, and the slides either side
are unshifted.

Co-Authored-By: Claude Opus 5 <noreply@anthropic.com>
</commit_message>
<xml_diff>
--- a/final_dissertation_presentation.pptx
+++ b/final_dissertation_presentation.pptx
@@ -40,6 +40,7 @@
     <p:sldId id="291" r:id="rId42"/>
     <p:sldId id="292" r:id="rId43"/>
     <p:sldId id="293" r:id="rId44"/>
+    <p:sldId id="294" r:id="rId45"/>
     <p:sldId id="267" r:id="rId18"/>
     <p:sldId id="268" r:id="rId19"/>
   </p:sldIdLst>
@@ -19889,7 +19890,7 @@
                   <a:srgbClr val="0B2B52"/>
                 </a:solidFill>
               </a:rPr>
-              <a:t>36</a:t>
+              <a:t>37</a:t>
             </a:r>
           </a:p>
         </p:txBody>
@@ -20618,7 +20619,7 @@
                   <a:srgbClr val="0B2B52"/>
                 </a:solidFill>
               </a:rPr>
-              <a:t>37</a:t>
+              <a:t>38</a:t>
             </a:r>
           </a:p>
         </p:txBody>
@@ -20809,6 +20810,802 @@
                 </a:solidFill>
               </a:rPr>
               <a:t>Thank you  ·  Questions welcome</a:t>
+            </a:r>
+          </a:p>
+        </p:txBody>
+      </p:sp>
+    </p:spTree>
+  </p:cSld>
+  <p:clrMapOvr>
+    <a:masterClrMapping/>
+  </p:clrMapOvr>
+</p:sld>
+</file>
+
+<file path=ppt/slides/slide38.xml><?xml version="1.0" encoding="utf-8"?>
+<p:sld xmlns:a="http://schemas.openxmlformats.org/drawingml/2006/main" xmlns:p="http://schemas.openxmlformats.org/presentationml/2006/main" xmlns:r="http://schemas.openxmlformats.org/officeDocument/2006/relationships">
+  <p:cSld>
+    <p:spTree>
+      <p:nvGrpSpPr>
+        <p:cNvPr id="1" name=""/>
+        <p:cNvGrpSpPr/>
+        <p:nvPr/>
+      </p:nvGrpSpPr>
+      <p:grpSpPr/>
+      <p:sp>
+        <p:nvSpPr>
+          <p:cNvPr id="2" name="Rectangle 1"/>
+          <p:cNvSpPr/>
+          <p:nvPr/>
+        </p:nvSpPr>
+        <p:spPr>
+          <a:xfrm>
+            <a:off x="0" y="0"/>
+            <a:ext cx="12188952" cy="914400"/>
+          </a:xfrm>
+          <a:prstGeom prst="rect">
+            <a:avLst/>
+          </a:prstGeom>
+          <a:solidFill>
+            <a:srgbClr val="0B2B52"/>
+          </a:solidFill>
+          <a:ln>
+            <a:noFill/>
+          </a:ln>
+        </p:spPr>
+        <p:style>
+          <a:lnRef idx="1">
+            <a:schemeClr val="accent1"/>
+          </a:lnRef>
+          <a:fillRef idx="3">
+            <a:schemeClr val="accent1"/>
+          </a:fillRef>
+          <a:effectRef idx="2">
+            <a:schemeClr val="accent1"/>
+          </a:effectRef>
+          <a:fontRef idx="minor">
+            <a:schemeClr val="lt1"/>
+          </a:fontRef>
+        </p:style>
+        <p:txBody>
+          <a:bodyPr rtlCol="0" anchor="ctr"/>
+          <a:lstStyle/>
+          <a:p>
+            <a:pPr algn="ctr"/>
+          </a:p>
+        </p:txBody>
+      </p:sp>
+      <p:sp>
+        <p:nvSpPr>
+          <p:cNvPr id="3" name="Rectangle 2"/>
+          <p:cNvSpPr/>
+          <p:nvPr/>
+        </p:nvSpPr>
+        <p:spPr>
+          <a:xfrm>
+            <a:off x="0" y="914400"/>
+            <a:ext cx="12188952" cy="54864"/>
+          </a:xfrm>
+          <a:prstGeom prst="rect">
+            <a:avLst/>
+          </a:prstGeom>
+          <a:solidFill>
+            <a:srgbClr val="1E6FB8"/>
+          </a:solidFill>
+          <a:ln>
+            <a:noFill/>
+          </a:ln>
+        </p:spPr>
+        <p:style>
+          <a:lnRef idx="1">
+            <a:schemeClr val="accent1"/>
+          </a:lnRef>
+          <a:fillRef idx="3">
+            <a:schemeClr val="accent1"/>
+          </a:fillRef>
+          <a:effectRef idx="2">
+            <a:schemeClr val="accent1"/>
+          </a:effectRef>
+          <a:fontRef idx="minor">
+            <a:schemeClr val="lt1"/>
+          </a:fontRef>
+        </p:style>
+        <p:txBody>
+          <a:bodyPr rtlCol="0" anchor="ctr"/>
+          <a:lstStyle/>
+          <a:p>
+            <a:pPr algn="ctr"/>
+          </a:p>
+        </p:txBody>
+      </p:sp>
+      <p:sp>
+        <p:nvSpPr>
+          <p:cNvPr id="4" name="TextBox 3"/>
+          <p:cNvSpPr txBox="1"/>
+          <p:nvPr/>
+        </p:nvSpPr>
+        <p:spPr>
+          <a:xfrm>
+            <a:off x="502920" y="109728"/>
+            <a:ext cx="11155680" cy="777240"/>
+          </a:xfrm>
+          <a:prstGeom prst="rect">
+            <a:avLst/>
+          </a:prstGeom>
+          <a:noFill/>
+        </p:spPr>
+        <p:txBody>
+          <a:bodyPr wrap="square">
+            <a:spAutoFit/>
+          </a:bodyPr>
+          <a:lstStyle/>
+          <a:p>
+            <a:pPr>
+              <a:spcAft>
+                <a:spcPts val="600"/>
+              </a:spcAft>
+            </a:pPr>
+            <a:r>
+              <a:rPr sz="2600" b="1">
+                <a:solidFill>
+                  <a:srgbClr val="FFFFFF"/>
+                </a:solidFill>
+              </a:rPr>
+              <a:t>Measured — Where the Scramble Control Stops Working</a:t>
+            </a:r>
+          </a:p>
+        </p:txBody>
+      </p:sp>
+      <p:sp>
+        <p:nvSpPr>
+          <p:cNvPr id="5" name="TextBox 4"/>
+          <p:cNvSpPr txBox="1"/>
+          <p:nvPr/>
+        </p:nvSpPr>
+        <p:spPr>
+          <a:xfrm>
+            <a:off x="502920" y="6473952"/>
+            <a:ext cx="8229600" cy="274320"/>
+          </a:xfrm>
+          <a:prstGeom prst="rect">
+            <a:avLst/>
+          </a:prstGeom>
+          <a:noFill/>
+        </p:spPr>
+        <p:txBody>
+          <a:bodyPr wrap="square">
+            <a:spAutoFit/>
+          </a:bodyPr>
+          <a:lstStyle/>
+          <a:p>
+            <a:pPr>
+              <a:spcAft>
+                <a:spcPts val="600"/>
+              </a:spcAft>
+            </a:pPr>
+            <a:r>
+              <a:rPr sz="900" b="0">
+                <a:solidFill>
+                  <a:srgbClr val="555555"/>
+                </a:solidFill>
+              </a:rPr>
+              <a:t>Boltz-Fast · Final Dissertation Report · Akik Jana (2024AB05287)</a:t>
+            </a:r>
+          </a:p>
+        </p:txBody>
+      </p:sp>
+      <p:sp>
+        <p:nvSpPr>
+          <p:cNvPr id="6" name="TextBox 5"/>
+          <p:cNvSpPr txBox="1"/>
+          <p:nvPr/>
+        </p:nvSpPr>
+        <p:spPr>
+          <a:xfrm>
+            <a:off x="11183112" y="6473952"/>
+            <a:ext cx="640080" cy="274320"/>
+          </a:xfrm>
+          <a:prstGeom prst="rect">
+            <a:avLst/>
+          </a:prstGeom>
+          <a:noFill/>
+        </p:spPr>
+        <p:txBody>
+          <a:bodyPr wrap="square">
+            <a:spAutoFit/>
+          </a:bodyPr>
+          <a:lstStyle/>
+          <a:p>
+            <a:pPr>
+              <a:spcAft>
+                <a:spcPts val="600"/>
+              </a:spcAft>
+            </a:pPr>
+            <a:r>
+              <a:rPr sz="1000" b="0">
+                <a:solidFill>
+                  <a:srgbClr val="0B2B52"/>
+                </a:solidFill>
+              </a:rPr>
+              <a:t>36</a:t>
+            </a:r>
+          </a:p>
+        </p:txBody>
+      </p:sp>
+      <p:sp>
+        <p:nvSpPr>
+          <p:cNvPr id="7" name="TextBox 6"/>
+          <p:cNvSpPr txBox="1"/>
+          <p:nvPr/>
+        </p:nvSpPr>
+        <p:spPr>
+          <a:xfrm>
+            <a:off x="548640" y="1051560"/>
+            <a:ext cx="11155680" cy="1005840"/>
+          </a:xfrm>
+          <a:prstGeom prst="rect">
+            <a:avLst/>
+          </a:prstGeom>
+          <a:noFill/>
+        </p:spPr>
+        <p:txBody>
+          <a:bodyPr wrap="square">
+            <a:spAutoFit/>
+          </a:bodyPr>
+          <a:lstStyle/>
+          <a:p>
+            <a:pPr>
+              <a:spcAft>
+                <a:spcPts val="600"/>
+              </a:spcAft>
+            </a:pPr>
+            <a:r>
+              <a:rPr sz="1500" b="0">
+                <a:solidFill>
+                  <a:srgbClr val="0B2B52"/>
+                </a:solidFill>
+              </a:rPr>
+              <a:t>38 of those designs folded as delivered and against permutations of themselves. The prediction below was</a:t>
+            </a:r>
+          </a:p>
+          <a:p>
+            <a:pPr>
+              <a:spcAft>
+                <a:spcPts val="600"/>
+              </a:spcAft>
+            </a:pPr>
+            <a:r>
+              <a:rPr sz="1500" b="0">
+                <a:solidFill>
+                  <a:srgbClr val="0B2B52"/>
+                </a:solidFill>
+              </a:rPr>
+              <a:t>written into the source and committed before any fold ran.</a:t>
+            </a:r>
+          </a:p>
+        </p:txBody>
+      </p:sp>
+      <p:graphicFrame>
+        <p:nvGraphicFramePr>
+          <p:cNvPr id="8" name="Table 7"/>
+          <p:cNvGraphicFramePr>
+            <a:graphicFrameLocks noGrp="1"/>
+          </p:cNvGraphicFramePr>
+          <p:nvPr/>
+        </p:nvGraphicFramePr>
+        <p:xfrm>
+          <a:off x="548640" y="1965960"/>
+          <a:ext cx="11155680" cy="1234440"/>
+        </p:xfrm>
+        <a:graphic>
+          <a:graphicData uri="http://schemas.openxmlformats.org/drawingml/2006/table">
+            <a:tbl>
+              <a:tblPr firstRow="1" bandRow="1">
+                <a:tableStyleId>{5C22544A-7EE6-4342-B048-85BDC9FD1C3A}</a:tableStyleId>
+              </a:tblPr>
+              <a:tblGrid>
+                <a:gridCol w="4023360"/>
+                <a:gridCol w="2377440"/>
+                <a:gridCol w="2560320"/>
+                <a:gridCol w="2194560"/>
+              </a:tblGrid>
+              <a:tr h="411480">
+                <a:tc>
+                  <a:txBody>
+                    <a:bodyPr/>
+                    <a:lstStyle/>
+                    <a:p/>
+                  </a:txBody>
+                  <a:tcPr/>
+                </a:tc>
+                <a:tc>
+                  <a:txBody>
+                    <a:bodyPr/>
+                    <a:lstStyle/>
+                    <a:p>
+                      <a:r>
+                        <a:rPr sz="1300" b="1">
+                          <a:solidFill>
+                            <a:srgbClr val="0B2B52"/>
+                          </a:solidFill>
+                        </a:rPr>
+                        <a:t>design</a:t>
+                      </a:r>
+                    </a:p>
+                  </a:txBody>
+                  <a:tcPr/>
+                </a:tc>
+                <a:tc>
+                  <a:txBody>
+                    <a:bodyPr/>
+                    <a:lstStyle/>
+                    <a:p>
+                      <a:r>
+                        <a:rPr sz="1300" b="1">
+                          <a:solidFill>
+                            <a:srgbClr val="0B2B52"/>
+                          </a:solidFill>
+                        </a:rPr>
+                        <a:t>its scrambles</a:t>
+                      </a:r>
+                    </a:p>
+                  </a:txBody>
+                  <a:tcPr/>
+                </a:tc>
+                <a:tc>
+                  <a:txBody>
+                    <a:bodyPr/>
+                    <a:lstStyle/>
+                    <a:p>
+                      <a:r>
+                        <a:rPr sz="1300" b="1">
+                          <a:solidFill>
+                            <a:srgbClr val="0B2B52"/>
+                          </a:solidFill>
+                        </a:rPr>
+                        <a:t>margin</a:t>
+                      </a:r>
+                    </a:p>
+                  </a:txBody>
+                  <a:tcPr/>
+                </a:tc>
+              </a:tr>
+              <a:tr h="411480">
+                <a:tc>
+                  <a:txBody>
+                    <a:bodyPr/>
+                    <a:lstStyle/>
+                    <a:p>
+                      <a:r>
+                        <a:rPr sz="1300" b="0">
+                          <a:solidFill>
+                            <a:srgbClr val="0B2B52"/>
+                          </a:solidFill>
+                        </a:rPr>
+                        <a:t>measured binders (20)</a:t>
+                      </a:r>
+                    </a:p>
+                  </a:txBody>
+                  <a:tcPr/>
+                </a:tc>
+                <a:tc>
+                  <a:txBody>
+                    <a:bodyPr/>
+                    <a:lstStyle/>
+                    <a:p>
+                      <a:r>
+                        <a:rPr sz="1300" b="0">
+                          <a:solidFill>
+                            <a:srgbClr val="0B2B52"/>
+                          </a:solidFill>
+                        </a:rPr>
+                        <a:t>72.99</a:t>
+                      </a:r>
+                    </a:p>
+                  </a:txBody>
+                  <a:tcPr/>
+                </a:tc>
+                <a:tc>
+                  <a:txBody>
+                    <a:bodyPr/>
+                    <a:lstStyle/>
+                    <a:p>
+                      <a:r>
+                        <a:rPr sz="1300" b="0">
+                          <a:solidFill>
+                            <a:srgbClr val="0B2B52"/>
+                          </a:solidFill>
+                        </a:rPr>
+                        <a:t>53.88</a:t>
+                      </a:r>
+                    </a:p>
+                  </a:txBody>
+                  <a:tcPr/>
+                </a:tc>
+                <a:tc>
+                  <a:txBody>
+                    <a:bodyPr/>
+                    <a:lstStyle/>
+                    <a:p>
+                      <a:r>
+                        <a:rPr sz="1300" b="0">
+                          <a:solidFill>
+                            <a:srgbClr val="0B2B52"/>
+                          </a:solidFill>
+                        </a:rPr>
+                        <a:t>+19.11</a:t>
+                      </a:r>
+                    </a:p>
+                  </a:txBody>
+                  <a:tcPr/>
+                </a:tc>
+              </a:tr>
+              <a:tr h="411480">
+                <a:tc>
+                  <a:txBody>
+                    <a:bodyPr/>
+                    <a:lstStyle/>
+                    <a:p>
+                      <a:r>
+                        <a:rPr sz="1300" b="0">
+                          <a:solidFill>
+                            <a:srgbClr val="0B2B52"/>
+                          </a:solidFill>
+                        </a:rPr>
+                        <a:t>measured non-binders (18)</a:t>
+                      </a:r>
+                    </a:p>
+                  </a:txBody>
+                  <a:tcPr/>
+                </a:tc>
+                <a:tc>
+                  <a:txBody>
+                    <a:bodyPr/>
+                    <a:lstStyle/>
+                    <a:p>
+                      <a:r>
+                        <a:rPr sz="1300" b="0">
+                          <a:solidFill>
+                            <a:srgbClr val="0B2B52"/>
+                          </a:solidFill>
+                        </a:rPr>
+                        <a:t>71.15</a:t>
+                      </a:r>
+                    </a:p>
+                  </a:txBody>
+                  <a:tcPr/>
+                </a:tc>
+                <a:tc>
+                  <a:txBody>
+                    <a:bodyPr/>
+                    <a:lstStyle/>
+                    <a:p>
+                      <a:r>
+                        <a:rPr sz="1300" b="0">
+                          <a:solidFill>
+                            <a:srgbClr val="0B2B52"/>
+                          </a:solidFill>
+                        </a:rPr>
+                        <a:t>53.22</a:t>
+                      </a:r>
+                    </a:p>
+                  </a:txBody>
+                  <a:tcPr/>
+                </a:tc>
+                <a:tc>
+                  <a:txBody>
+                    <a:bodyPr/>
+                    <a:lstStyle/>
+                    <a:p>
+                      <a:r>
+                        <a:rPr sz="1300" b="0">
+                          <a:solidFill>
+                            <a:srgbClr val="0B2B52"/>
+                          </a:solidFill>
+                        </a:rPr>
+                        <a:t>+17.93</a:t>
+                      </a:r>
+                    </a:p>
+                  </a:txBody>
+                  <a:tcPr/>
+                </a:tc>
+              </a:tr>
+            </a:tbl>
+          </a:graphicData>
+        </a:graphic>
+      </p:graphicFrame>
+      <p:sp>
+        <p:nvSpPr>
+          <p:cNvPr id="9" name="Rounded Rectangle 8"/>
+          <p:cNvSpPr/>
+          <p:nvPr/>
+        </p:nvSpPr>
+        <p:spPr>
+          <a:xfrm>
+            <a:off x="548640" y="3429000"/>
+            <a:ext cx="3520440" cy="1463040"/>
+          </a:xfrm>
+          <a:prstGeom prst="roundRect">
+            <a:avLst/>
+          </a:prstGeom>
+          <a:solidFill>
+            <a:srgbClr val="C62828"/>
+          </a:solidFill>
+          <a:ln>
+            <a:noFill/>
+          </a:ln>
+        </p:spPr>
+        <p:style>
+          <a:lnRef idx="1">
+            <a:schemeClr val="accent1"/>
+          </a:lnRef>
+          <a:fillRef idx="3">
+            <a:schemeClr val="accent1"/>
+          </a:fillRef>
+          <a:effectRef idx="2">
+            <a:schemeClr val="accent1"/>
+          </a:effectRef>
+          <a:fontRef idx="minor">
+            <a:schemeClr val="lt1"/>
+          </a:fontRef>
+        </p:style>
+        <p:txBody>
+          <a:bodyPr rtlCol="0" anchor="ctr" wrap="square"/>
+          <a:lstStyle/>
+          <a:p>
+            <a:pPr algn="ctr"/>
+            <a:r>
+              <a:rPr sz="2300" b="1">
+                <a:solidFill>
+                  <a:srgbClr val="FFFFFF"/>
+                </a:solidFill>
+              </a:rPr>
+              <a:t>p = 0.751</a:t>
+            </a:r>
+          </a:p>
+          <a:p>
+            <a:pPr algn="ctr"/>
+            <a:r>
+              <a:rPr sz="1050">
+                <a:solidFill>
+                  <a:srgbClr val="FFFFFF"/>
+                </a:solidFill>
+              </a:rPr>
+              <a:t>the two margins are indistinguishable</a:t>
+            </a:r>
+          </a:p>
+        </p:txBody>
+      </p:sp>
+      <p:sp>
+        <p:nvSpPr>
+          <p:cNvPr id="10" name="Rounded Rectangle 9"/>
+          <p:cNvSpPr/>
+          <p:nvPr/>
+        </p:nvSpPr>
+        <p:spPr>
+          <a:xfrm>
+            <a:off x="4343400" y="3429000"/>
+            <a:ext cx="3520440" cy="1463040"/>
+          </a:xfrm>
+          <a:prstGeom prst="roundRect">
+            <a:avLst/>
+          </a:prstGeom>
+          <a:solidFill>
+            <a:srgbClr val="C62828"/>
+          </a:solidFill>
+          <a:ln>
+            <a:noFill/>
+          </a:ln>
+        </p:spPr>
+        <p:style>
+          <a:lnRef idx="1">
+            <a:schemeClr val="accent1"/>
+          </a:lnRef>
+          <a:fillRef idx="3">
+            <a:schemeClr val="accent1"/>
+          </a:fillRef>
+          <a:effectRef idx="2">
+            <a:schemeClr val="accent1"/>
+          </a:effectRef>
+          <a:fontRef idx="minor">
+            <a:schemeClr val="lt1"/>
+          </a:fontRef>
+        </p:style>
+        <p:txBody>
+          <a:bodyPr rtlCol="0" anchor="ctr" wrap="square"/>
+          <a:lstStyle/>
+          <a:p>
+            <a:pPr algn="ctr"/>
+            <a:r>
+              <a:rPr sz="2300" b="1">
+                <a:solidFill>
+                  <a:srgbClr val="FFFFFF"/>
+                </a:solidFill>
+              </a:rPr>
+              <a:t>0.672 → 0.581</a:t>
+            </a:r>
+          </a:p>
+          <a:p>
+            <a:pPr algn="ctr"/>
+            <a:r>
+              <a:rPr sz="1050">
+                <a:solidFill>
+                  <a:srgbClr val="FFFFFF"/>
+                </a:solidFill>
+              </a:rPr>
+              <a:t>AUC, before and after subtracting scrambles</a:t>
+            </a:r>
+          </a:p>
+        </p:txBody>
+      </p:sp>
+      <p:sp>
+        <p:nvSpPr>
+          <p:cNvPr id="11" name="Rounded Rectangle 10"/>
+          <p:cNvSpPr/>
+          <p:nvPr/>
+        </p:nvSpPr>
+        <p:spPr>
+          <a:xfrm>
+            <a:off x="8138160" y="3429000"/>
+            <a:ext cx="3566160" cy="1463040"/>
+          </a:xfrm>
+          <a:prstGeom prst="roundRect">
+            <a:avLst/>
+          </a:prstGeom>
+          <a:solidFill>
+            <a:srgbClr val="1E6FB8"/>
+          </a:solidFill>
+          <a:ln>
+            <a:noFill/>
+          </a:ln>
+        </p:spPr>
+        <p:style>
+          <a:lnRef idx="1">
+            <a:schemeClr val="accent1"/>
+          </a:lnRef>
+          <a:fillRef idx="3">
+            <a:schemeClr val="accent1"/>
+          </a:fillRef>
+          <a:effectRef idx="2">
+            <a:schemeClr val="accent1"/>
+          </a:effectRef>
+          <a:fontRef idx="minor">
+            <a:schemeClr val="lt1"/>
+          </a:fontRef>
+        </p:style>
+        <p:txBody>
+          <a:bodyPr rtlCol="0" anchor="ctr" wrap="square"/>
+          <a:lstStyle/>
+          <a:p>
+            <a:pPr algn="ctr"/>
+            <a:r>
+              <a:rPr sz="2300" b="1">
+                <a:solidFill>
+                  <a:srgbClr val="FFFFFF"/>
+                </a:solidFill>
+              </a:rPr>
+              <a:t>−0.092</a:t>
+            </a:r>
+          </a:p>
+          <a:p>
+            <a:pPr algn="ctr"/>
+            <a:r>
+              <a:rPr sz="1050">
+                <a:solidFill>
+                  <a:srgbClr val="FFFFFF"/>
+                </a:solidFill>
+              </a:rPr>
+              <a:t>change in AUC, CI [−0.170, +0.008]</a:t>
+            </a:r>
+          </a:p>
+        </p:txBody>
+      </p:sp>
+      <p:sp>
+        <p:nvSpPr>
+          <p:cNvPr id="12" name="Rounded Rectangle 11"/>
+          <p:cNvSpPr/>
+          <p:nvPr/>
+        </p:nvSpPr>
+        <p:spPr>
+          <a:xfrm>
+            <a:off x="548640" y="5029200"/>
+            <a:ext cx="11155680" cy="960120"/>
+          </a:xfrm>
+          <a:prstGeom prst="roundRect">
+            <a:avLst/>
+          </a:prstGeom>
+          <a:solidFill>
+            <a:srgbClr val="2E7D32"/>
+          </a:solidFill>
+          <a:ln>
+            <a:noFill/>
+          </a:ln>
+        </p:spPr>
+        <p:style>
+          <a:lnRef idx="1">
+            <a:schemeClr val="accent1"/>
+          </a:lnRef>
+          <a:fillRef idx="3">
+            <a:schemeClr val="accent1"/>
+          </a:fillRef>
+          <a:effectRef idx="2">
+            <a:schemeClr val="accent1"/>
+          </a:effectRef>
+          <a:fontRef idx="minor">
+            <a:schemeClr val="lt1"/>
+          </a:fontRef>
+        </p:style>
+        <p:txBody>
+          <a:bodyPr rtlCol="0" anchor="ctr" wrap="square"/>
+          <a:lstStyle/>
+          <a:p>
+            <a:pPr algn="ctr">
+              <a:spcAft>
+                <a:spcPts val="600"/>
+              </a:spcAft>
+            </a:pPr>
+            <a:r>
+              <a:rPr sz="1700" b="1">
+                <a:solidFill>
+                  <a:srgbClr val="FFFFFF"/>
+                </a:solidFill>
+              </a:rPr>
+              <a:t>A permutation of a 15-residue peptide is still a plausible ligand. A permutation of a 100-residue protein is not a protein.</a:t>
+            </a:r>
+          </a:p>
+        </p:txBody>
+      </p:sp>
+      <p:sp>
+        <p:nvSpPr>
+          <p:cNvPr id="13" name="Rounded Rectangle 12"/>
+          <p:cNvSpPr/>
+          <p:nvPr/>
+        </p:nvSpPr>
+        <p:spPr>
+          <a:xfrm>
+            <a:off x="548640" y="5532120"/>
+            <a:ext cx="11155680" cy="868680"/>
+          </a:xfrm>
+          <a:prstGeom prst="roundRect">
+            <a:avLst/>
+          </a:prstGeom>
+          <a:solidFill>
+            <a:srgbClr val="FDF3E0"/>
+          </a:solidFill>
+          <a:ln>
+            <a:noFill/>
+          </a:ln>
+        </p:spPr>
+        <p:style>
+          <a:lnRef idx="1">
+            <a:schemeClr val="accent1"/>
+          </a:lnRef>
+          <a:fillRef idx="3">
+            <a:schemeClr val="accent1"/>
+          </a:fillRef>
+          <a:effectRef idx="2">
+            <a:schemeClr val="accent1"/>
+          </a:effectRef>
+          <a:fontRef idx="minor">
+            <a:schemeClr val="lt1"/>
+          </a:fontRef>
+        </p:style>
+        <p:txBody>
+          <a:bodyPr rtlCol="0" anchor="ctr" wrap="square"/>
+          <a:lstStyle/>
+          <a:p>
+            <a:pPr algn="ctr">
+              <a:spcAft>
+                <a:spcPts val="600"/>
+              </a:spcAft>
+            </a:pPr>
+            <a:r>
+              <a:rPr sz="1250" b="0">
+                <a:solidFill>
+                  <a:srgbClr val="8A5200"/>
+                </a:solidFill>
+              </a:rPr>
+              <a:t>So the control is sound for the case this work concerns and unsound outside it. The recommendation gains a condition rather than losing its force: use the scramble control wherever a permutation of the candidate is still a candidate.</a:t>
             </a:r>
           </a:p>
         </p:txBody>

</xml_diff>